<commit_message>
Date: 11 Apr 2026
</commit_message>
<xml_diff>
--- a/Data Driven Framework.pptx
+++ b/Data Driven Framework.pptx
@@ -108,6 +108,11 @@
       </a:defRPr>
     </a:lvl9pPr>
   </p:defaultTextStyle>
+  <p:extLst>
+    <p:ext uri="{EFAFB233-063F-42B5-8137-9DF3F51BA10A}">
+      <p15:sldGuideLst xmlns:p15="http://schemas.microsoft.com/office/powerpoint/2012/main"/>
+    </p:ext>
+  </p:extLst>
 </p:presentation>
 </file>
 
@@ -1982,14 +1987,35 @@
         </dgm:presLayoutVars>
       </dgm:prSet>
       <dgm:spPr/>
+      <dgm:t>
+        <a:bodyPr/>
+        <a:lstStyle/>
+        <a:p>
+          <a:endParaRPr lang="en-IN"/>
+        </a:p>
+      </dgm:t>
     </dgm:pt>
     <dgm:pt modelId="{695F0A32-B390-4EC8-B6C3-91DCE6BAB6BE}" type="pres">
       <dgm:prSet presAssocID="{7EFD851E-67E9-4F2B-98C5-E91BA5DB1069}" presName="sibTrans" presStyleLbl="sibTrans2D1" presStyleIdx="0" presStyleCnt="3"/>
       <dgm:spPr/>
+      <dgm:t>
+        <a:bodyPr/>
+        <a:lstStyle/>
+        <a:p>
+          <a:endParaRPr lang="en-IN"/>
+        </a:p>
+      </dgm:t>
     </dgm:pt>
     <dgm:pt modelId="{78F2DDB9-68B9-452E-AD23-C8A3B79E8302}" type="pres">
       <dgm:prSet presAssocID="{7EFD851E-67E9-4F2B-98C5-E91BA5DB1069}" presName="connectorText" presStyleLbl="sibTrans2D1" presStyleIdx="0" presStyleCnt="3"/>
       <dgm:spPr/>
+      <dgm:t>
+        <a:bodyPr/>
+        <a:lstStyle/>
+        <a:p>
+          <a:endParaRPr lang="en-IN"/>
+        </a:p>
+      </dgm:t>
     </dgm:pt>
     <dgm:pt modelId="{9C18B2E4-6AB6-4F6D-9936-DAFDCB4FE1D4}" type="pres">
       <dgm:prSet presAssocID="{F7634697-4B45-488E-9147-51C5A8327E07}" presName="node" presStyleLbl="node1" presStyleIdx="1" presStyleCnt="4">
@@ -1998,14 +2024,35 @@
         </dgm:presLayoutVars>
       </dgm:prSet>
       <dgm:spPr/>
+      <dgm:t>
+        <a:bodyPr/>
+        <a:lstStyle/>
+        <a:p>
+          <a:endParaRPr lang="en-IN"/>
+        </a:p>
+      </dgm:t>
     </dgm:pt>
     <dgm:pt modelId="{8252D1A7-D8A4-4FCA-BDD5-3CC8A53FDEDB}" type="pres">
       <dgm:prSet presAssocID="{4775EC50-A784-4506-9C94-1303927C1C50}" presName="sibTrans" presStyleLbl="sibTrans2D1" presStyleIdx="1" presStyleCnt="3"/>
       <dgm:spPr/>
+      <dgm:t>
+        <a:bodyPr/>
+        <a:lstStyle/>
+        <a:p>
+          <a:endParaRPr lang="en-IN"/>
+        </a:p>
+      </dgm:t>
     </dgm:pt>
     <dgm:pt modelId="{7529973E-7047-4D65-AFA8-7E07D9E8F42D}" type="pres">
       <dgm:prSet presAssocID="{4775EC50-A784-4506-9C94-1303927C1C50}" presName="connectorText" presStyleLbl="sibTrans2D1" presStyleIdx="1" presStyleCnt="3"/>
       <dgm:spPr/>
+      <dgm:t>
+        <a:bodyPr/>
+        <a:lstStyle/>
+        <a:p>
+          <a:endParaRPr lang="en-IN"/>
+        </a:p>
+      </dgm:t>
     </dgm:pt>
     <dgm:pt modelId="{D55CB519-2E29-427C-9E20-A8C08FAB0728}" type="pres">
       <dgm:prSet presAssocID="{51E5FF59-6B13-477D-B83D-B400AB281354}" presName="node" presStyleLbl="node1" presStyleIdx="2" presStyleCnt="4">
@@ -2014,14 +2061,35 @@
         </dgm:presLayoutVars>
       </dgm:prSet>
       <dgm:spPr/>
+      <dgm:t>
+        <a:bodyPr/>
+        <a:lstStyle/>
+        <a:p>
+          <a:endParaRPr lang="en-IN"/>
+        </a:p>
+      </dgm:t>
     </dgm:pt>
     <dgm:pt modelId="{F9940C8B-2138-4EC1-998C-00C8BCE91CE3}" type="pres">
       <dgm:prSet presAssocID="{484F32A7-EF80-4D58-AF16-5647DD4E6D84}" presName="sibTrans" presStyleLbl="sibTrans2D1" presStyleIdx="2" presStyleCnt="3"/>
       <dgm:spPr/>
+      <dgm:t>
+        <a:bodyPr/>
+        <a:lstStyle/>
+        <a:p>
+          <a:endParaRPr lang="en-IN"/>
+        </a:p>
+      </dgm:t>
     </dgm:pt>
     <dgm:pt modelId="{08122F0E-284A-416D-8759-80913B919A7D}" type="pres">
       <dgm:prSet presAssocID="{484F32A7-EF80-4D58-AF16-5647DD4E6D84}" presName="connectorText" presStyleLbl="sibTrans2D1" presStyleIdx="2" presStyleCnt="3"/>
       <dgm:spPr/>
+      <dgm:t>
+        <a:bodyPr/>
+        <a:lstStyle/>
+        <a:p>
+          <a:endParaRPr lang="en-IN"/>
+        </a:p>
+      </dgm:t>
     </dgm:pt>
     <dgm:pt modelId="{FD51746B-2C20-433E-8325-06DB8229A248}" type="pres">
       <dgm:prSet presAssocID="{797C5FFB-F998-43A9-855B-3364A5D3C817}" presName="node" presStyleLbl="node1" presStyleIdx="3" presStyleCnt="4">
@@ -2030,15 +2098,22 @@
         </dgm:presLayoutVars>
       </dgm:prSet>
       <dgm:spPr/>
+      <dgm:t>
+        <a:bodyPr/>
+        <a:lstStyle/>
+        <a:p>
+          <a:endParaRPr lang="en-IN"/>
+        </a:p>
+      </dgm:t>
     </dgm:pt>
   </dgm:ptLst>
   <dgm:cxnLst>
     <dgm:cxn modelId="{896DE301-13C2-4532-89B9-371647A0427C}" type="presOf" srcId="{4775EC50-A784-4506-9C94-1303927C1C50}" destId="{7529973E-7047-4D65-AFA8-7E07D9E8F42D}" srcOrd="1" destOrd="0" presId="urn:microsoft.com/office/officeart/2005/8/layout/process2"/>
+    <dgm:cxn modelId="{204A853D-CEF8-4EF8-88EF-E3504DFCF948}" srcId="{7D41E985-5910-47F6-816D-B87DF72E4290}" destId="{797C5FFB-F998-43A9-855B-3364A5D3C817}" srcOrd="3" destOrd="0" parTransId="{0B64440C-AB7C-4F99-B3D7-D01EAD9AE7AB}" sibTransId="{DB0825F2-06DF-4D05-8919-3AF6BC09027A}"/>
     <dgm:cxn modelId="{418534B9-F8C9-47ED-9369-350C9B2DFD9E}" type="presOf" srcId="{F7634697-4B45-488E-9147-51C5A8327E07}" destId="{9C18B2E4-6AB6-4F6D-9936-DAFDCB4FE1D4}" srcOrd="0" destOrd="0" presId="urn:microsoft.com/office/officeart/2005/8/layout/process2"/>
-    <dgm:cxn modelId="{204A853D-CEF8-4EF8-88EF-E3504DFCF948}" srcId="{7D41E985-5910-47F6-816D-B87DF72E4290}" destId="{797C5FFB-F998-43A9-855B-3364A5D3C817}" srcOrd="3" destOrd="0" parTransId="{0B64440C-AB7C-4F99-B3D7-D01EAD9AE7AB}" sibTransId="{DB0825F2-06DF-4D05-8919-3AF6BC09027A}"/>
     <dgm:cxn modelId="{D2024208-BE06-4445-AD00-C8B56FF455D0}" type="presOf" srcId="{484F32A7-EF80-4D58-AF16-5647DD4E6D84}" destId="{F9940C8B-2138-4EC1-998C-00C8BCE91CE3}" srcOrd="0" destOrd="0" presId="urn:microsoft.com/office/officeart/2005/8/layout/process2"/>
+    <dgm:cxn modelId="{E240535E-2AE2-4C46-8EC6-E4D2D300791F}" type="presOf" srcId="{7EFD851E-67E9-4F2B-98C5-E91BA5DB1069}" destId="{78F2DDB9-68B9-452E-AD23-C8A3B79E8302}" srcOrd="1" destOrd="0" presId="urn:microsoft.com/office/officeart/2005/8/layout/process2"/>
     <dgm:cxn modelId="{D348D9FD-BFF8-4D57-BE1F-A882D1696888}" type="presOf" srcId="{7D41E985-5910-47F6-816D-B87DF72E4290}" destId="{F5226628-50A9-46E5-87ED-4C1F505711B5}" srcOrd="0" destOrd="0" presId="urn:microsoft.com/office/officeart/2005/8/layout/process2"/>
-    <dgm:cxn modelId="{E240535E-2AE2-4C46-8EC6-E4D2D300791F}" type="presOf" srcId="{7EFD851E-67E9-4F2B-98C5-E91BA5DB1069}" destId="{78F2DDB9-68B9-452E-AD23-C8A3B79E8302}" srcOrd="1" destOrd="0" presId="urn:microsoft.com/office/officeart/2005/8/layout/process2"/>
     <dgm:cxn modelId="{FA46020F-4432-46E8-BD03-1D3FFA07D733}" srcId="{7D41E985-5910-47F6-816D-B87DF72E4290}" destId="{51E5FF59-6B13-477D-B83D-B400AB281354}" srcOrd="2" destOrd="0" parTransId="{631BD7C1-FC9C-4992-AD9D-2C664EB45AC0}" sibTransId="{484F32A7-EF80-4D58-AF16-5647DD4E6D84}"/>
     <dgm:cxn modelId="{3A77DCEA-7251-4286-855E-0A28A7A2A36B}" type="presOf" srcId="{4775EC50-A784-4506-9C94-1303927C1C50}" destId="{8252D1A7-D8A4-4FCA-BDD5-3CC8A53FDEDB}" srcOrd="0" destOrd="0" presId="urn:microsoft.com/office/officeart/2005/8/layout/process2"/>
     <dgm:cxn modelId="{563BBD4E-CA80-4A59-9EAA-4CF86D1DDF2A}" type="presOf" srcId="{82620BE3-C3B0-47F3-8B35-37041AAF2461}" destId="{1DEC23D7-35F7-40D6-8323-1987ADA5B9F6}" srcOrd="0" destOrd="0" presId="urn:microsoft.com/office/officeart/2005/8/layout/process2"/>
@@ -2169,6 +2244,13 @@
         </dgm:presLayoutVars>
       </dgm:prSet>
       <dgm:spPr/>
+      <dgm:t>
+        <a:bodyPr/>
+        <a:lstStyle/>
+        <a:p>
+          <a:endParaRPr lang="en-IN"/>
+        </a:p>
+      </dgm:t>
     </dgm:pt>
     <dgm:pt modelId="{FC7CB5A8-1E33-4F60-A91B-477816AABF00}" type="pres">
       <dgm:prSet presAssocID="{55FAFC95-8203-4A0F-9334-7389CCD8F986}" presName="parTxOnlySpace" presStyleCnt="0"/>
@@ -2183,6 +2265,13 @@
         </dgm:presLayoutVars>
       </dgm:prSet>
       <dgm:spPr/>
+      <dgm:t>
+        <a:bodyPr/>
+        <a:lstStyle/>
+        <a:p>
+          <a:endParaRPr lang="en-IN"/>
+        </a:p>
+      </dgm:t>
     </dgm:pt>
   </dgm:ptLst>
   <dgm:cxnLst>
@@ -6523,7 +6612,7 @@
             <a:fld id="{B61BEF0D-F0BB-DE4B-95CE-6DB70DBA9567}" type="datetimeFigureOut">
               <a:rPr lang="en-US" dirty="0"/>
               <a:pPr/>
-              <a:t>4/5/2026</a:t>
+              <a:t>4/11/2026</a:t>
             </a:fld>
             <a:endParaRPr lang="en-US" dirty="0"/>
           </a:p>
@@ -6771,7 +6860,7 @@
             <a:fld id="{B61BEF0D-F0BB-DE4B-95CE-6DB70DBA9567}" type="datetimeFigureOut">
               <a:rPr lang="en-US" dirty="0"/>
               <a:pPr/>
-              <a:t>4/5/2026</a:t>
+              <a:t>4/11/2026</a:t>
             </a:fld>
             <a:endParaRPr lang="en-US" dirty="0"/>
           </a:p>
@@ -7082,7 +7171,7 @@
             <a:fld id="{B61BEF0D-F0BB-DE4B-95CE-6DB70DBA9567}" type="datetimeFigureOut">
               <a:rPr lang="en-US" dirty="0"/>
               <a:pPr/>
-              <a:t>4/5/2026</a:t>
+              <a:t>4/11/2026</a:t>
             </a:fld>
             <a:endParaRPr lang="en-US" dirty="0"/>
           </a:p>
@@ -7420,7 +7509,7 @@
             <a:fld id="{B61BEF0D-F0BB-DE4B-95CE-6DB70DBA9567}" type="datetimeFigureOut">
               <a:rPr lang="en-US" dirty="0"/>
               <a:pPr/>
-              <a:t>4/5/2026</a:t>
+              <a:t>4/11/2026</a:t>
             </a:fld>
             <a:endParaRPr lang="en-US" dirty="0"/>
           </a:p>
@@ -7731,7 +7820,7 @@
             <a:fld id="{B61BEF0D-F0BB-DE4B-95CE-6DB70DBA9567}" type="datetimeFigureOut">
               <a:rPr lang="en-US" dirty="0"/>
               <a:pPr/>
-              <a:t>4/5/2026</a:t>
+              <a:t>4/11/2026</a:t>
             </a:fld>
             <a:endParaRPr lang="en-US" dirty="0"/>
           </a:p>
@@ -8121,7 +8210,7 @@
             <a:fld id="{B61BEF0D-F0BB-DE4B-95CE-6DB70DBA9567}" type="datetimeFigureOut">
               <a:rPr lang="en-US" dirty="0"/>
               <a:pPr/>
-              <a:t>4/5/2026</a:t>
+              <a:t>4/11/2026</a:t>
             </a:fld>
             <a:endParaRPr lang="en-US" dirty="0"/>
           </a:p>
@@ -8287,7 +8376,7 @@
           <a:p>
             <a:fld id="{55C6B4A9-1611-4792-9094-5F34BCA07E0B}" type="datetimeFigureOut">
               <a:rPr lang="en-US" dirty="0"/>
-              <a:t>4/5/2026</a:t>
+              <a:t>4/11/2026</a:t>
             </a:fld>
             <a:endParaRPr lang="en-US" dirty="0"/>
           </a:p>
@@ -8463,7 +8552,7 @@
             <a:fld id="{B61BEF0D-F0BB-DE4B-95CE-6DB70DBA9567}" type="datetimeFigureOut">
               <a:rPr lang="en-US" dirty="0"/>
               <a:pPr/>
-              <a:t>4/5/2026</a:t>
+              <a:t>4/11/2026</a:t>
             </a:fld>
             <a:endParaRPr lang="en-US" dirty="0"/>
           </a:p>
@@ -8636,7 +8725,7 @@
             <a:fld id="{B61BEF0D-F0BB-DE4B-95CE-6DB70DBA9567}" type="datetimeFigureOut">
               <a:rPr lang="en-US" dirty="0"/>
               <a:pPr/>
-              <a:t>4/5/2026</a:t>
+              <a:t>4/11/2026</a:t>
             </a:fld>
             <a:endParaRPr lang="en-US" dirty="0"/>
           </a:p>
@@ -8880,7 +8969,7 @@
             <a:fld id="{B61BEF0D-F0BB-DE4B-95CE-6DB70DBA9567}" type="datetimeFigureOut">
               <a:rPr lang="en-US" dirty="0"/>
               <a:pPr/>
-              <a:t>4/5/2026</a:t>
+              <a:t>4/11/2026</a:t>
             </a:fld>
             <a:endParaRPr lang="en-US" dirty="0"/>
           </a:p>
@@ -9108,7 +9197,7 @@
           <a:p>
             <a:fld id="{EB712588-04B1-427B-82EE-E8DB90309F08}" type="datetimeFigureOut">
               <a:rPr lang="en-US" dirty="0"/>
-              <a:t>4/5/2026</a:t>
+              <a:t>4/11/2026</a:t>
             </a:fld>
             <a:endParaRPr lang="en-US" dirty="0"/>
           </a:p>
@@ -9478,7 +9567,7 @@
             <a:fld id="{B61BEF0D-F0BB-DE4B-95CE-6DB70DBA9567}" type="datetimeFigureOut">
               <a:rPr lang="en-US" dirty="0"/>
               <a:pPr/>
-              <a:t>4/5/2026</a:t>
+              <a:t>4/11/2026</a:t>
             </a:fld>
             <a:endParaRPr lang="en-US" dirty="0"/>
           </a:p>
@@ -9598,7 +9687,7 @@
             <a:fld id="{B61BEF0D-F0BB-DE4B-95CE-6DB70DBA9567}" type="datetimeFigureOut">
               <a:rPr lang="en-US" dirty="0"/>
               <a:pPr/>
-              <a:t>4/5/2026</a:t>
+              <a:t>4/11/2026</a:t>
             </a:fld>
             <a:endParaRPr lang="en-US" dirty="0"/>
           </a:p>
@@ -9690,7 +9779,7 @@
             <a:fld id="{B61BEF0D-F0BB-DE4B-95CE-6DB70DBA9567}" type="datetimeFigureOut">
               <a:rPr lang="en-US" dirty="0"/>
               <a:pPr/>
-              <a:t>4/5/2026</a:t>
+              <a:t>4/11/2026</a:t>
             </a:fld>
             <a:endParaRPr lang="en-US" dirty="0"/>
           </a:p>
@@ -9941,7 +10030,7 @@
           <a:p>
             <a:fld id="{42A54C80-263E-416B-A8E0-580EDEADCBDC}" type="datetimeFigureOut">
               <a:rPr lang="en-US" dirty="0"/>
-              <a:t>4/5/2026</a:t>
+              <a:t>4/11/2026</a:t>
             </a:fld>
             <a:endParaRPr lang="en-US" dirty="0"/>
           </a:p>
@@ -10200,7 +10289,7 @@
             <a:fld id="{B61BEF0D-F0BB-DE4B-95CE-6DB70DBA9567}" type="datetimeFigureOut">
               <a:rPr lang="en-US" dirty="0"/>
               <a:pPr/>
-              <a:t>4/5/2026</a:t>
+              <a:t>4/11/2026</a:t>
             </a:fld>
             <a:endParaRPr lang="en-US" dirty="0"/>
           </a:p>
@@ -10940,7 +11029,7 @@
             <a:fld id="{B61BEF0D-F0BB-DE4B-95CE-6DB70DBA9567}" type="datetimeFigureOut">
               <a:rPr lang="en-US" dirty="0"/>
               <a:pPr/>
-              <a:t>4/5/2026</a:t>
+              <a:t>4/11/2026</a:t>
             </a:fld>
             <a:endParaRPr lang="en-US" dirty="0"/>
           </a:p>
@@ -11838,7 +11927,11 @@
             <a:pPr algn="ctr"/>
             <a:r>
               <a:rPr lang="en-US" dirty="0" smtClean="0"/>
-              <a:t>FileOutputStream</a:t>
+              <a:t>FileOutputStream </a:t>
+            </a:r>
+            <a:r>
+              <a:rPr lang="en-US" smtClean="0"/>
+              <a:t>(Writing)</a:t>
             </a:r>
             <a:endParaRPr lang="en-IN" dirty="0"/>
           </a:p>
@@ -11882,7 +11975,7 @@
             <a:pPr algn="ctr"/>
             <a:r>
               <a:rPr lang="en-US" dirty="0" smtClean="0"/>
-              <a:t>FileInputStream</a:t>
+              <a:t>FileInputStream (Reading)</a:t>
             </a:r>
             <a:endParaRPr lang="en-IN" dirty="0"/>
           </a:p>

</xml_diff>